<commit_message>
Update project name to AI-Based Document Similarity & Duplicate Detection System Using NLP
</commit_message>
<xml_diff>
--- a/AI_Document_OCR_Scanner_Similarity_Detector_PBL.pptx
+++ b/AI_Document_OCR_Scanner_Similarity_Detector_PBL.pptx
@@ -3135,8 +3135,8 @@
         </p:nvSpPr>
         <p:spPr>
           <a:xfrm>
-            <a:off x="685800" y="274320"/>
-            <a:ext cx="10817352" cy="1188720"/>
+            <a:off x="685800" y="182880"/>
+            <a:ext cx="10817352" cy="1280160"/>
           </a:xfrm>
           <a:prstGeom prst="rect">
             <a:avLst/>
@@ -3150,7 +3150,7 @@
           <a:lstStyle/>
           <a:p>
             <a:pPr algn="ctr">
-              <a:defRPr sz="3200" b="1">
+              <a:defRPr sz="2800" b="1">
                 <a:solidFill>
                   <a:srgbClr val="38BDF8"/>
                 </a:solidFill>
@@ -3158,7 +3158,7 @@
               </a:defRPr>
             </a:pPr>
             <a:r>
-              <a:t>AI Document OCR Scanner &amp; Similarity Detector</a:t>
+              <a:t>AI-Based Document Similarity &amp; Duplicate Detection System Using NLP</a:t>
             </a:r>
           </a:p>
           <a:p>
@@ -7094,7 +7094,7 @@
       </p:sp>
       <p:pic>
         <p:nvPicPr>
-          <p:cNvPr id="4" name="Picture 3" descr="latest_ui_scan.png"/>
+          <p:cNvPr id="4" name="Picture 3" descr="ui_sandbox.png"/>
           <p:cNvPicPr>
             <a:picLocks noChangeAspect="1"/>
           </p:cNvPicPr>
@@ -7650,7 +7650,7 @@
       </p:sp>
       <p:pic>
         <p:nvPicPr>
-          <p:cNvPr id="4" name="Picture 3" descr="latest_ui_scan.png"/>
+          <p:cNvPr id="4" name="Picture 3" descr="ui_sandbox.png"/>
           <p:cNvPicPr>
             <a:picLocks noChangeAspect="1"/>
           </p:cNvPicPr>

</xml_diff>

<commit_message>
Clear Name and Enrollment values to blank placeholders on slide 1
</commit_message>
<xml_diff>
--- a/AI_Document_OCR_Scanner_Similarity_Detector_PBL.pptx
+++ b/AI_Document_OCR_Scanner_Similarity_Detector_PBL.pptx
@@ -3306,7 +3306,7 @@
                 </a:solidFill>
                 <a:latin typeface="Segoe UI"/>
               </a:rPr>
-              <a:t>Nimavat Jaydeep M.</a:t>
+              <a:t/>
             </a:r>
           </a:p>
         </p:txBody>
@@ -3392,7 +3392,7 @@
                 </a:solidFill>
                 <a:latin typeface="Segoe UI"/>
               </a:rPr>
-              <a:t>250043107032</a:t>
+              <a:t/>
             </a:r>
           </a:p>
         </p:txBody>

</xml_diff>

<commit_message>
Update Title Slide to support two group members side-by-side
</commit_message>
<xml_diff>
--- a/AI_Document_OCR_Scanner_Similarity_Detector_PBL.pptx
+++ b/AI_Document_OCR_Scanner_Similarity_Detector_PBL.pptx
@@ -3276,8 +3276,8 @@
         </p:nvSpPr>
         <p:spPr>
           <a:xfrm>
-            <a:off x="1097280" y="2651760"/>
-            <a:ext cx="4572000" cy="548640"/>
+            <a:off x="1097280" y="2560320"/>
+            <a:ext cx="4572000" cy="1005840"/>
           </a:xfrm>
           <a:prstGeom prst="rect">
             <a:avLst/>
@@ -3285,28 +3285,53 @@
           <a:noFill/>
         </p:spPr>
         <p:txBody>
-          <a:bodyPr wrap="none">
+          <a:bodyPr wrap="square">
             <a:spAutoFit/>
           </a:bodyPr>
           <a:lstStyle/>
           <a:p>
             <a:r>
-              <a:rPr b="1" sz="1800">
+              <a:rPr b="1" sz="1700">
                 <a:solidFill>
                   <a:srgbClr val="38BDF8"/>
                 </a:solidFill>
                 <a:latin typeface="Segoe UI"/>
               </a:rPr>
-              <a:t>NAME: </a:t>
-            </a:r>
-            <a:r>
-              <a:rPr sz="1800">
+              <a:t>NAME 1: </a:t>
+            </a:r>
+            <a:r>
+              <a:rPr sz="1700">
                 <a:solidFill>
                   <a:srgbClr val="FFFFFF"/>
                 </a:solidFill>
                 <a:latin typeface="Segoe UI"/>
               </a:rPr>
-              <a:t/>
+              <a:t>Nimavat Jaydeep M.</a:t>
+            </a:r>
+          </a:p>
+          <a:p>
+            <a:pPr>
+              <a:spcBef>
+                <a:spcPts val="400"/>
+              </a:spcBef>
+            </a:pPr>
+            <a:r>
+              <a:rPr b="1" sz="1700">
+                <a:solidFill>
+                  <a:srgbClr val="38BDF8"/>
+                </a:solidFill>
+                <a:latin typeface="Segoe UI"/>
+              </a:rPr>
+              <a:t>ENROLLMENT 1: </a:t>
+            </a:r>
+            <a:r>
+              <a:rPr sz="1700">
+                <a:solidFill>
+                  <a:srgbClr val="FFFFFF"/>
+                </a:solidFill>
+                <a:latin typeface="Segoe UI"/>
+              </a:rPr>
+              <a:t>250043107032</a:t>
             </a:r>
           </a:p>
         </p:txBody>
@@ -3319,8 +3344,8 @@
         </p:nvSpPr>
         <p:spPr>
           <a:xfrm>
-            <a:off x="6217920" y="2651760"/>
-            <a:ext cx="4572000" cy="548640"/>
+            <a:off x="6217920" y="2560320"/>
+            <a:ext cx="4572000" cy="1005840"/>
           </a:xfrm>
           <a:prstGeom prst="rect">
             <a:avLst/>
@@ -3328,28 +3353,53 @@
           <a:noFill/>
         </p:spPr>
         <p:txBody>
-          <a:bodyPr wrap="none">
+          <a:bodyPr wrap="square">
             <a:spAutoFit/>
           </a:bodyPr>
           <a:lstStyle/>
           <a:p>
             <a:r>
-              <a:rPr b="1" sz="1800">
+              <a:rPr b="1" sz="1700">
                 <a:solidFill>
                   <a:srgbClr val="38BDF8"/>
                 </a:solidFill>
                 <a:latin typeface="Segoe UI"/>
               </a:rPr>
-              <a:t>BRANCH: </a:t>
-            </a:r>
-            <a:r>
-              <a:rPr sz="1800">
+              <a:t>NAME 2: </a:t>
+            </a:r>
+            <a:r>
+              <a:rPr sz="1700">
                 <a:solidFill>
                   <a:srgbClr val="FFFFFF"/>
                 </a:solidFill>
                 <a:latin typeface="Segoe UI"/>
               </a:rPr>
-              <a:t>Computer Engineering</a:t>
+              <a:t>Upadhyay Hitarth S.</a:t>
+            </a:r>
+          </a:p>
+          <a:p>
+            <a:pPr>
+              <a:spcBef>
+                <a:spcPts val="400"/>
+              </a:spcBef>
+            </a:pPr>
+            <a:r>
+              <a:rPr b="1" sz="1700">
+                <a:solidFill>
+                  <a:srgbClr val="38BDF8"/>
+                </a:solidFill>
+                <a:latin typeface="Segoe UI"/>
+              </a:rPr>
+              <a:t>ENROLLMENT 2: </a:t>
+            </a:r>
+            <a:r>
+              <a:rPr sz="1700">
+                <a:solidFill>
+                  <a:srgbClr val="FFFFFF"/>
+                </a:solidFill>
+                <a:latin typeface="Segoe UI"/>
+              </a:rPr>
+              <a:t>250043107050</a:t>
             </a:r>
           </a:p>
         </p:txBody>
@@ -3362,93 +3412,7 @@
         </p:nvSpPr>
         <p:spPr>
           <a:xfrm>
-            <a:off x="1097280" y="3474720"/>
-            <a:ext cx="4572000" cy="548640"/>
-          </a:xfrm>
-          <a:prstGeom prst="rect">
-            <a:avLst/>
-          </a:prstGeom>
-          <a:noFill/>
-        </p:spPr>
-        <p:txBody>
-          <a:bodyPr wrap="none">
-            <a:spAutoFit/>
-          </a:bodyPr>
-          <a:lstStyle/>
-          <a:p>
-            <a:r>
-              <a:rPr b="1" sz="1800">
-                <a:solidFill>
-                  <a:srgbClr val="38BDF8"/>
-                </a:solidFill>
-                <a:latin typeface="Segoe UI"/>
-              </a:rPr>
-              <a:t>ENROLLMENT: </a:t>
-            </a:r>
-            <a:r>
-              <a:rPr sz="1800">
-                <a:solidFill>
-                  <a:srgbClr val="FFFFFF"/>
-                </a:solidFill>
-                <a:latin typeface="Segoe UI"/>
-              </a:rPr>
-              <a:t/>
-            </a:r>
-          </a:p>
-        </p:txBody>
-      </p:sp>
-      <p:sp>
-        <p:nvSpPr>
-          <p:cNvPr id="8" name="TextBox 7"/>
-          <p:cNvSpPr txBox="1"/>
-          <p:nvPr/>
-        </p:nvSpPr>
-        <p:spPr>
-          <a:xfrm>
-            <a:off x="6217920" y="3474720"/>
-            <a:ext cx="4572000" cy="548640"/>
-          </a:xfrm>
-          <a:prstGeom prst="rect">
-            <a:avLst/>
-          </a:prstGeom>
-          <a:noFill/>
-        </p:spPr>
-        <p:txBody>
-          <a:bodyPr wrap="none">
-            <a:spAutoFit/>
-          </a:bodyPr>
-          <a:lstStyle/>
-          <a:p>
-            <a:r>
-              <a:rPr b="1" sz="1800">
-                <a:solidFill>
-                  <a:srgbClr val="38BDF8"/>
-                </a:solidFill>
-                <a:latin typeface="Segoe UI"/>
-              </a:rPr>
-              <a:t>SEMESTER: </a:t>
-            </a:r>
-            <a:r>
-              <a:rPr sz="1800">
-                <a:solidFill>
-                  <a:srgbClr val="FFFFFF"/>
-                </a:solidFill>
-                <a:latin typeface="Segoe UI"/>
-              </a:rPr>
-              <a:t>5th</a:t>
-            </a:r>
-          </a:p>
-        </p:txBody>
-      </p:sp>
-      <p:sp>
-        <p:nvSpPr>
-          <p:cNvPr id="9" name="TextBox 8"/>
-          <p:cNvSpPr txBox="1"/>
-          <p:nvPr/>
-        </p:nvSpPr>
-        <p:spPr>
-          <a:xfrm>
-            <a:off x="1097280" y="4572000"/>
+            <a:off x="1097280" y="3931920"/>
             <a:ext cx="9966960" cy="548640"/>
           </a:xfrm>
           <a:prstGeom prst="rect">
@@ -3464,16 +3428,78 @@
           <a:p>
             <a:pPr algn="ctr"/>
             <a:r>
-              <a:rPr b="1" sz="1800">
+              <a:rPr b="1" sz="1700">
                 <a:solidFill>
                   <a:srgbClr val="38BDF8"/>
                 </a:solidFill>
                 <a:latin typeface="Segoe UI"/>
               </a:rPr>
+              <a:t>BRANCH: </a:t>
+            </a:r>
+            <a:r>
+              <a:rPr sz="1700">
+                <a:solidFill>
+                  <a:srgbClr val="FFFFFF"/>
+                </a:solidFill>
+                <a:latin typeface="Segoe UI"/>
+              </a:rPr>
+              <a:t>Computer Engineering     |     </a:t>
+            </a:r>
+            <a:r>
+              <a:rPr b="1" sz="1700">
+                <a:solidFill>
+                  <a:srgbClr val="38BDF8"/>
+                </a:solidFill>
+                <a:latin typeface="Segoe UI"/>
+              </a:rPr>
+              <a:t>SEMESTER: </a:t>
+            </a:r>
+            <a:r>
+              <a:rPr sz="1700">
+                <a:solidFill>
+                  <a:srgbClr val="FFFFFF"/>
+                </a:solidFill>
+                <a:latin typeface="Segoe UI"/>
+              </a:rPr>
+              <a:t>5th</a:t>
+            </a:r>
+          </a:p>
+        </p:txBody>
+      </p:sp>
+      <p:sp>
+        <p:nvSpPr>
+          <p:cNvPr id="8" name="TextBox 7"/>
+          <p:cNvSpPr txBox="1"/>
+          <p:nvPr/>
+        </p:nvSpPr>
+        <p:spPr>
+          <a:xfrm>
+            <a:off x="1097280" y="4663440"/>
+            <a:ext cx="9966960" cy="548640"/>
+          </a:xfrm>
+          <a:prstGeom prst="rect">
+            <a:avLst/>
+          </a:prstGeom>
+          <a:noFill/>
+        </p:spPr>
+        <p:txBody>
+          <a:bodyPr wrap="none">
+            <a:spAutoFit/>
+          </a:bodyPr>
+          <a:lstStyle/>
+          <a:p>
+            <a:pPr algn="ctr"/>
+            <a:r>
+              <a:rPr b="1" sz="1700">
+                <a:solidFill>
+                  <a:srgbClr val="38BDF8"/>
+                </a:solidFill>
+                <a:latin typeface="Segoe UI"/>
+              </a:rPr>
               <a:t>COLLEGE: </a:t>
             </a:r>
             <a:r>
-              <a:rPr sz="1800">
+              <a:rPr sz="1700">
                 <a:solidFill>
                   <a:srgbClr val="FFFFFF"/>
                 </a:solidFill>

</xml_diff>